<commit_message>
slides(bbq): enlarge answers and simplify paper references
</commit_message>
<xml_diff>
--- a/slides/datasets-in-10-minutes-bbq.pptx
+++ b/slides/datasets-in-10-minutes-bbq.pptx
@@ -7674,8 +7674,8 @@
         </p:nvSpPr>
         <p:spPr>
           <a:xfrm>
-            <a:off x="6583680" y="1271016"/>
-            <a:ext cx="1965960" cy="201168"/>
+            <a:off x="5303520" y="1216152"/>
+            <a:ext cx="3246120" cy="384048"/>
           </a:xfrm>
           <a:prstGeom prst="rect">
             <a:avLst/>
@@ -7683,14 +7683,14 @@
           <a:noFill/>
         </p:spPr>
         <p:txBody>
-          <a:bodyPr wrap="square" lIns="0" rIns="0" tIns="0" bIns="0">
+          <a:bodyPr wrap="none" lIns="0" rIns="0" tIns="0" bIns="0">
             <a:noAutofit/>
           </a:bodyPr>
           <a:lstStyle/>
           <a:p>
-            <a:pPr algn="l">
-              <a:lnSpc>
-                <a:spcPct val="117000"/>
+            <a:pPr algn="r">
+              <a:lnSpc>
+                <a:spcPts val="2640"/>
               </a:lnSpc>
               <a:spcBef>
                 <a:spcPts val="0"/>
@@ -7707,7 +7707,7 @@
               </a:defRPr>
             </a:pPr>
             <a:r>
-              <a:rPr sz="1250" b="1" lang="ja-JP" altLang="en-US">
+              <a:rPr sz="2200" b="1" lang="ja-JP" altLang="en-US">
                 <a:solidFill>
                   <a:srgbClr val="2C9100"/>
                 </a:solidFill>
@@ -8287,8 +8287,8 @@
         </p:nvSpPr>
         <p:spPr>
           <a:xfrm>
-            <a:off x="6583680" y="1271016"/>
-            <a:ext cx="1965960" cy="201168"/>
+            <a:off x="5303520" y="1216152"/>
+            <a:ext cx="3246120" cy="384048"/>
           </a:xfrm>
           <a:prstGeom prst="rect">
             <a:avLst/>
@@ -8296,14 +8296,14 @@
           <a:noFill/>
         </p:spPr>
         <p:txBody>
-          <a:bodyPr wrap="square" lIns="0" rIns="0" tIns="0" bIns="0">
+          <a:bodyPr wrap="none" lIns="0" rIns="0" tIns="0" bIns="0">
             <a:noAutofit/>
           </a:bodyPr>
           <a:lstStyle/>
           <a:p>
-            <a:pPr algn="l">
-              <a:lnSpc>
-                <a:spcPct val="117000"/>
+            <a:pPr algn="r">
+              <a:lnSpc>
+                <a:spcPts val="2640"/>
               </a:lnSpc>
               <a:spcBef>
                 <a:spcPts val="0"/>
@@ -8320,7 +8320,7 @@
               </a:defRPr>
             </a:pPr>
             <a:r>
-              <a:rPr sz="1250" b="1" lang="ja-JP" altLang="en-US">
+              <a:rPr sz="2200" b="1" lang="ja-JP" altLang="en-US">
                 <a:solidFill>
                   <a:srgbClr val="2C9100"/>
                 </a:solidFill>
@@ -8779,8 +8779,8 @@
         </p:nvSpPr>
         <p:spPr>
           <a:xfrm>
-            <a:off x="6583680" y="1271016"/>
-            <a:ext cx="1965960" cy="201168"/>
+            <a:off x="5303520" y="1216152"/>
+            <a:ext cx="3246120" cy="384048"/>
           </a:xfrm>
           <a:prstGeom prst="rect">
             <a:avLst/>
@@ -8788,14 +8788,14 @@
           <a:noFill/>
         </p:spPr>
         <p:txBody>
-          <a:bodyPr wrap="square" lIns="0" rIns="0" tIns="0" bIns="0">
+          <a:bodyPr wrap="none" lIns="0" rIns="0" tIns="0" bIns="0">
             <a:noAutofit/>
           </a:bodyPr>
           <a:lstStyle/>
           <a:p>
-            <a:pPr algn="l">
-              <a:lnSpc>
-                <a:spcPct val="117000"/>
+            <a:pPr algn="r">
+              <a:lnSpc>
+                <a:spcPts val="2640"/>
               </a:lnSpc>
               <a:spcBef>
                 <a:spcPts val="0"/>
@@ -8812,7 +8812,7 @@
               </a:defRPr>
             </a:pPr>
             <a:r>
-              <a:rPr sz="1250" b="1" lang="ja-JP" altLang="en-US">
+              <a:rPr sz="2200" b="1" lang="ja-JP" altLang="en-US">
                 <a:solidFill>
                   <a:srgbClr val="2C9100"/>
                 </a:solidFill>
@@ -12116,7 +12116,7 @@
                 <a:ea typeface="Noto Sans CJK JP"/>
                 <a:cs typeface="Noto Sans"/>
               </a:rPr>
-              <a:t>論文Figures 2–3。平均正解率だけでなく、質問と属性ごとの向きを調べた。</a:t>
+              <a:t>平均正解率だけでなく、質問と属性ごとの向きを調べた。</a:t>
             </a:r>
           </a:p>
         </p:txBody>
@@ -15007,8 +15007,8 @@
         </p:nvSpPr>
         <p:spPr>
           <a:xfrm>
-            <a:off x="6583680" y="1271016"/>
-            <a:ext cx="1965960" cy="201168"/>
+            <a:off x="5303520" y="1216152"/>
+            <a:ext cx="3246120" cy="384048"/>
           </a:xfrm>
           <a:prstGeom prst="rect">
             <a:avLst/>
@@ -15016,14 +15016,14 @@
           <a:noFill/>
         </p:spPr>
         <p:txBody>
-          <a:bodyPr wrap="square" lIns="0" rIns="0" tIns="0" bIns="0">
+          <a:bodyPr wrap="none" lIns="0" rIns="0" tIns="0" bIns="0">
             <a:noAutofit/>
           </a:bodyPr>
           <a:lstStyle/>
           <a:p>
-            <a:pPr algn="l">
-              <a:lnSpc>
-                <a:spcPct val="117000"/>
+            <a:pPr algn="r">
+              <a:lnSpc>
+                <a:spcPts val="2640"/>
               </a:lnSpc>
               <a:spcBef>
                 <a:spcPts val="0"/>
@@ -15040,7 +15040,7 @@
               </a:defRPr>
             </a:pPr>
             <a:r>
-              <a:rPr sz="1250" b="1" lang="ja-JP" altLang="en-US">
+              <a:rPr sz="2200" b="1" lang="ja-JP" altLang="en-US">
                 <a:solidFill>
                   <a:srgbClr val="2C9100"/>
                 </a:solidFill>
@@ -15558,8 +15558,8 @@
         </p:nvSpPr>
         <p:spPr>
           <a:xfrm>
-            <a:off x="6583680" y="1271016"/>
-            <a:ext cx="1965960" cy="201168"/>
+            <a:off x="5303520" y="1216152"/>
+            <a:ext cx="3246120" cy="384048"/>
           </a:xfrm>
           <a:prstGeom prst="rect">
             <a:avLst/>
@@ -15567,14 +15567,14 @@
           <a:noFill/>
         </p:spPr>
         <p:txBody>
-          <a:bodyPr wrap="square" lIns="0" rIns="0" tIns="0" bIns="0">
+          <a:bodyPr wrap="none" lIns="0" rIns="0" tIns="0" bIns="0">
             <a:noAutofit/>
           </a:bodyPr>
           <a:lstStyle/>
           <a:p>
-            <a:pPr algn="l">
-              <a:lnSpc>
-                <a:spcPct val="117000"/>
+            <a:pPr algn="r">
+              <a:lnSpc>
+                <a:spcPts val="2640"/>
               </a:lnSpc>
               <a:spcBef>
                 <a:spcPts val="0"/>
@@ -15591,7 +15591,7 @@
               </a:defRPr>
             </a:pPr>
             <a:r>
-              <a:rPr sz="1250" b="1" lang="ja-JP" altLang="en-US">
+              <a:rPr sz="2200" b="1" lang="ja-JP" altLang="en-US">
                 <a:solidFill>
                   <a:srgbClr val="2C9100"/>
                 </a:solidFill>
@@ -16047,8 +16047,8 @@
         </p:nvSpPr>
         <p:spPr>
           <a:xfrm>
-            <a:off x="6583680" y="1271016"/>
-            <a:ext cx="1965960" cy="201168"/>
+            <a:off x="5303520" y="1216152"/>
+            <a:ext cx="3246120" cy="384048"/>
           </a:xfrm>
           <a:prstGeom prst="rect">
             <a:avLst/>
@@ -16056,14 +16056,14 @@
           <a:noFill/>
         </p:spPr>
         <p:txBody>
-          <a:bodyPr wrap="square" lIns="0" rIns="0" tIns="0" bIns="0">
+          <a:bodyPr wrap="none" lIns="0" rIns="0" tIns="0" bIns="0">
             <a:noAutofit/>
           </a:bodyPr>
           <a:lstStyle/>
           <a:p>
-            <a:pPr algn="l">
-              <a:lnSpc>
-                <a:spcPct val="117000"/>
+            <a:pPr algn="r">
+              <a:lnSpc>
+                <a:spcPts val="2640"/>
               </a:lnSpc>
               <a:spcBef>
                 <a:spcPts val="0"/>
@@ -16080,7 +16080,7 @@
               </a:defRPr>
             </a:pPr>
             <a:r>
-              <a:rPr sz="1250" b="1" lang="ja-JP" altLang="en-US">
+              <a:rPr sz="2200" b="1" lang="ja-JP" altLang="en-US">
                 <a:solidFill>
                   <a:srgbClr val="2C9100"/>
                 </a:solidFill>
@@ -16663,8 +16663,8 @@
         </p:nvSpPr>
         <p:spPr>
           <a:xfrm>
-            <a:off x="6583680" y="1271016"/>
-            <a:ext cx="1965960" cy="201168"/>
+            <a:off x="5303520" y="1216152"/>
+            <a:ext cx="3246120" cy="384048"/>
           </a:xfrm>
           <a:prstGeom prst="rect">
             <a:avLst/>
@@ -16672,14 +16672,14 @@
           <a:noFill/>
         </p:spPr>
         <p:txBody>
-          <a:bodyPr wrap="square" lIns="0" rIns="0" tIns="0" bIns="0">
+          <a:bodyPr wrap="none" lIns="0" rIns="0" tIns="0" bIns="0">
             <a:noAutofit/>
           </a:bodyPr>
           <a:lstStyle/>
           <a:p>
-            <a:pPr algn="l">
-              <a:lnSpc>
-                <a:spcPct val="117000"/>
+            <a:pPr algn="r">
+              <a:lnSpc>
+                <a:spcPts val="2640"/>
               </a:lnSpc>
               <a:spcBef>
                 <a:spcPts val="0"/>
@@ -16696,7 +16696,7 @@
               </a:defRPr>
             </a:pPr>
             <a:r>
-              <a:rPr sz="1250" b="1" lang="ja-JP" altLang="en-US">
+              <a:rPr sz="2200" b="1" lang="ja-JP" altLang="en-US">
                 <a:solidFill>
                   <a:srgbClr val="2C9100"/>
                 </a:solidFill>
@@ -17093,8 +17093,8 @@
         </p:nvSpPr>
         <p:spPr>
           <a:xfrm>
-            <a:off x="6583680" y="1271016"/>
-            <a:ext cx="1965960" cy="201168"/>
+            <a:off x="5303520" y="1216152"/>
+            <a:ext cx="3246120" cy="384048"/>
           </a:xfrm>
           <a:prstGeom prst="rect">
             <a:avLst/>
@@ -17102,14 +17102,14 @@
           <a:noFill/>
         </p:spPr>
         <p:txBody>
-          <a:bodyPr wrap="square" lIns="0" rIns="0" tIns="0" bIns="0">
+          <a:bodyPr wrap="none" lIns="0" rIns="0" tIns="0" bIns="0">
             <a:noAutofit/>
           </a:bodyPr>
           <a:lstStyle/>
           <a:p>
-            <a:pPr algn="l">
-              <a:lnSpc>
-                <a:spcPct val="117000"/>
+            <a:pPr algn="r">
+              <a:lnSpc>
+                <a:spcPts val="2640"/>
               </a:lnSpc>
               <a:spcBef>
                 <a:spcPts val="0"/>
@@ -17126,7 +17126,7 @@
               </a:defRPr>
             </a:pPr>
             <a:r>
-              <a:rPr sz="1250" b="1" lang="ja-JP" altLang="en-US">
+              <a:rPr sz="2200" b="1" lang="ja-JP" altLang="en-US">
                 <a:solidFill>
                   <a:srgbClr val="2C9100"/>
                 </a:solidFill>
@@ -17523,8 +17523,8 @@
         </p:nvSpPr>
         <p:spPr>
           <a:xfrm>
-            <a:off x="6583680" y="1271016"/>
-            <a:ext cx="1965960" cy="201168"/>
+            <a:off x="5303520" y="1216152"/>
+            <a:ext cx="3246120" cy="384048"/>
           </a:xfrm>
           <a:prstGeom prst="rect">
             <a:avLst/>
@@ -17532,14 +17532,14 @@
           <a:noFill/>
         </p:spPr>
         <p:txBody>
-          <a:bodyPr wrap="square" lIns="0" rIns="0" tIns="0" bIns="0">
+          <a:bodyPr wrap="none" lIns="0" rIns="0" tIns="0" bIns="0">
             <a:noAutofit/>
           </a:bodyPr>
           <a:lstStyle/>
           <a:p>
-            <a:pPr algn="l">
-              <a:lnSpc>
-                <a:spcPct val="117000"/>
+            <a:pPr algn="r">
+              <a:lnSpc>
+                <a:spcPts val="2640"/>
               </a:lnSpc>
               <a:spcBef>
                 <a:spcPts val="0"/>
@@ -17556,7 +17556,7 @@
               </a:defRPr>
             </a:pPr>
             <a:r>
-              <a:rPr sz="1250" b="1" lang="ja-JP" altLang="en-US">
+              <a:rPr sz="2200" b="1" lang="ja-JP" altLang="en-US">
                 <a:solidFill>
                   <a:srgbClr val="2C9100"/>
                 </a:solidFill>
@@ -18139,8 +18139,8 @@
         </p:nvSpPr>
         <p:spPr>
           <a:xfrm>
-            <a:off x="6583680" y="1271016"/>
-            <a:ext cx="1965960" cy="201168"/>
+            <a:off x="5303520" y="1216152"/>
+            <a:ext cx="3246120" cy="384048"/>
           </a:xfrm>
           <a:prstGeom prst="rect">
             <a:avLst/>
@@ -18148,14 +18148,14 @@
           <a:noFill/>
         </p:spPr>
         <p:txBody>
-          <a:bodyPr wrap="square" lIns="0" rIns="0" tIns="0" bIns="0">
+          <a:bodyPr wrap="none" lIns="0" rIns="0" tIns="0" bIns="0">
             <a:noAutofit/>
           </a:bodyPr>
           <a:lstStyle/>
           <a:p>
-            <a:pPr algn="l">
-              <a:lnSpc>
-                <a:spcPct val="117000"/>
+            <a:pPr algn="r">
+              <a:lnSpc>
+                <a:spcPts val="2640"/>
               </a:lnSpc>
               <a:spcBef>
                 <a:spcPts val="0"/>
@@ -18172,7 +18172,7 @@
               </a:defRPr>
             </a:pPr>
             <a:r>
-              <a:rPr sz="1250" b="1" lang="ja-JP" altLang="en-US">
+              <a:rPr sz="2200" b="1" lang="ja-JP" altLang="en-US">
                 <a:solidFill>
                   <a:srgbClr val="2C9100"/>
                 </a:solidFill>
@@ -18755,8 +18755,8 @@
         </p:nvSpPr>
         <p:spPr>
           <a:xfrm>
-            <a:off x="6583680" y="1271016"/>
-            <a:ext cx="1965960" cy="201168"/>
+            <a:off x="5303520" y="1216152"/>
+            <a:ext cx="3246120" cy="384048"/>
           </a:xfrm>
           <a:prstGeom prst="rect">
             <a:avLst/>
@@ -18764,14 +18764,14 @@
           <a:noFill/>
         </p:spPr>
         <p:txBody>
-          <a:bodyPr wrap="square" lIns="0" rIns="0" tIns="0" bIns="0">
+          <a:bodyPr wrap="none" lIns="0" rIns="0" tIns="0" bIns="0">
             <a:noAutofit/>
           </a:bodyPr>
           <a:lstStyle/>
           <a:p>
-            <a:pPr algn="l">
-              <a:lnSpc>
-                <a:spcPct val="117000"/>
+            <a:pPr algn="r">
+              <a:lnSpc>
+                <a:spcPts val="2640"/>
               </a:lnSpc>
               <a:spcBef>
                 <a:spcPts val="0"/>
@@ -18788,7 +18788,7 @@
               </a:defRPr>
             </a:pPr>
             <a:r>
-              <a:rPr sz="1250" b="1" lang="ja-JP" altLang="en-US">
+              <a:rPr sz="2200" b="1" lang="ja-JP" altLang="en-US">
                 <a:solidFill>
                   <a:srgbClr val="2C9100"/>
                 </a:solidFill>
@@ -19185,8 +19185,8 @@
         </p:nvSpPr>
         <p:spPr>
           <a:xfrm>
-            <a:off x="6583680" y="1271016"/>
-            <a:ext cx="1965960" cy="201168"/>
+            <a:off x="5303520" y="1216152"/>
+            <a:ext cx="3246120" cy="384048"/>
           </a:xfrm>
           <a:prstGeom prst="rect">
             <a:avLst/>
@@ -19194,14 +19194,14 @@
           <a:noFill/>
         </p:spPr>
         <p:txBody>
-          <a:bodyPr wrap="square" lIns="0" rIns="0" tIns="0" bIns="0">
+          <a:bodyPr wrap="none" lIns="0" rIns="0" tIns="0" bIns="0">
             <a:noAutofit/>
           </a:bodyPr>
           <a:lstStyle/>
           <a:p>
-            <a:pPr algn="l">
-              <a:lnSpc>
-                <a:spcPct val="117000"/>
+            <a:pPr algn="r">
+              <a:lnSpc>
+                <a:spcPts val="2640"/>
               </a:lnSpc>
               <a:spcBef>
                 <a:spcPts val="0"/>
@@ -19218,7 +19218,7 @@
               </a:defRPr>
             </a:pPr>
             <a:r>
-              <a:rPr sz="1250" b="1" lang="ja-JP" altLang="en-US">
+              <a:rPr sz="2200" b="1" lang="ja-JP" altLang="en-US">
                 <a:solidFill>
                   <a:srgbClr val="2C9100"/>
                 </a:solidFill>
@@ -19798,8 +19798,8 @@
         </p:nvSpPr>
         <p:spPr>
           <a:xfrm>
-            <a:off x="6583680" y="1271016"/>
-            <a:ext cx="1965960" cy="201168"/>
+            <a:off x="5303520" y="1216152"/>
+            <a:ext cx="3246120" cy="384048"/>
           </a:xfrm>
           <a:prstGeom prst="rect">
             <a:avLst/>
@@ -19807,14 +19807,14 @@
           <a:noFill/>
         </p:spPr>
         <p:txBody>
-          <a:bodyPr wrap="square" lIns="0" rIns="0" tIns="0" bIns="0">
+          <a:bodyPr wrap="none" lIns="0" rIns="0" tIns="0" bIns="0">
             <a:noAutofit/>
           </a:bodyPr>
           <a:lstStyle/>
           <a:p>
-            <a:pPr algn="l">
-              <a:lnSpc>
-                <a:spcPct val="117000"/>
+            <a:pPr algn="r">
+              <a:lnSpc>
+                <a:spcPts val="2640"/>
               </a:lnSpc>
               <a:spcBef>
                 <a:spcPts val="0"/>
@@ -19831,7 +19831,7 @@
               </a:defRPr>
             </a:pPr>
             <a:r>
-              <a:rPr sz="1250" b="1" lang="ja-JP" altLang="en-US">
+              <a:rPr sz="2200" b="1" lang="ja-JP" altLang="en-US">
                 <a:solidFill>
                   <a:srgbClr val="2C9100"/>
                 </a:solidFill>
@@ -20339,8 +20339,8 @@
         </p:nvSpPr>
         <p:spPr>
           <a:xfrm>
-            <a:off x="6583680" y="1271016"/>
-            <a:ext cx="1965960" cy="201168"/>
+            <a:off x="5303520" y="1216152"/>
+            <a:ext cx="3246120" cy="384048"/>
           </a:xfrm>
           <a:prstGeom prst="rect">
             <a:avLst/>
@@ -20348,14 +20348,14 @@
           <a:noFill/>
         </p:spPr>
         <p:txBody>
-          <a:bodyPr wrap="square" lIns="0" rIns="0" tIns="0" bIns="0">
+          <a:bodyPr wrap="none" lIns="0" rIns="0" tIns="0" bIns="0">
             <a:noAutofit/>
           </a:bodyPr>
           <a:lstStyle/>
           <a:p>
-            <a:pPr algn="l">
-              <a:lnSpc>
-                <a:spcPct val="117000"/>
+            <a:pPr algn="r">
+              <a:lnSpc>
+                <a:spcPts val="2640"/>
               </a:lnSpc>
               <a:spcBef>
                 <a:spcPts val="0"/>
@@ -20372,7 +20372,7 @@
               </a:defRPr>
             </a:pPr>
             <a:r>
-              <a:rPr sz="1250" b="1" lang="ja-JP" altLang="en-US">
+              <a:rPr sz="2200" b="1" lang="ja-JP" altLang="en-US">
                 <a:solidFill>
                   <a:srgbClr val="2C9100"/>
                 </a:solidFill>
@@ -20955,8 +20955,8 @@
         </p:nvSpPr>
         <p:spPr>
           <a:xfrm>
-            <a:off x="6583680" y="1271016"/>
-            <a:ext cx="1965960" cy="201168"/>
+            <a:off x="5303520" y="1216152"/>
+            <a:ext cx="3246120" cy="384048"/>
           </a:xfrm>
           <a:prstGeom prst="rect">
             <a:avLst/>
@@ -20964,14 +20964,14 @@
           <a:noFill/>
         </p:spPr>
         <p:txBody>
-          <a:bodyPr wrap="square" lIns="0" rIns="0" tIns="0" bIns="0">
+          <a:bodyPr wrap="none" lIns="0" rIns="0" tIns="0" bIns="0">
             <a:noAutofit/>
           </a:bodyPr>
           <a:lstStyle/>
           <a:p>
-            <a:pPr algn="l">
-              <a:lnSpc>
-                <a:spcPct val="117000"/>
+            <a:pPr algn="r">
+              <a:lnSpc>
+                <a:spcPts val="2640"/>
               </a:lnSpc>
               <a:spcBef>
                 <a:spcPts val="0"/>
@@ -20988,7 +20988,7 @@
               </a:defRPr>
             </a:pPr>
             <a:r>
-              <a:rPr sz="1250" b="1" lang="ja-JP" altLang="en-US">
+              <a:rPr sz="2200" b="1" lang="ja-JP" altLang="en-US">
                 <a:solidFill>
                   <a:srgbClr val="2C9100"/>
                 </a:solidFill>
@@ -21385,8 +21385,8 @@
         </p:nvSpPr>
         <p:spPr>
           <a:xfrm>
-            <a:off x="6583680" y="1271016"/>
-            <a:ext cx="1965960" cy="201168"/>
+            <a:off x="5303520" y="1216152"/>
+            <a:ext cx="3246120" cy="384048"/>
           </a:xfrm>
           <a:prstGeom prst="rect">
             <a:avLst/>
@@ -21394,14 +21394,14 @@
           <a:noFill/>
         </p:spPr>
         <p:txBody>
-          <a:bodyPr wrap="square" lIns="0" rIns="0" tIns="0" bIns="0">
+          <a:bodyPr wrap="none" lIns="0" rIns="0" tIns="0" bIns="0">
             <a:noAutofit/>
           </a:bodyPr>
           <a:lstStyle/>
           <a:p>
-            <a:pPr algn="l">
-              <a:lnSpc>
-                <a:spcPct val="117000"/>
+            <a:pPr algn="r">
+              <a:lnSpc>
+                <a:spcPts val="2640"/>
               </a:lnSpc>
               <a:spcBef>
                 <a:spcPts val="0"/>
@@ -21418,7 +21418,7 @@
               </a:defRPr>
             </a:pPr>
             <a:r>
-              <a:rPr sz="1250" b="1" lang="ja-JP" altLang="en-US">
+              <a:rPr sz="2200" b="1" lang="ja-JP" altLang="en-US">
                 <a:solidFill>
                   <a:srgbClr val="2C9100"/>
                 </a:solidFill>
@@ -22001,8 +22001,8 @@
         </p:nvSpPr>
         <p:spPr>
           <a:xfrm>
-            <a:off x="6583680" y="1271016"/>
-            <a:ext cx="1965960" cy="201168"/>
+            <a:off x="5303520" y="1216152"/>
+            <a:ext cx="3246120" cy="384048"/>
           </a:xfrm>
           <a:prstGeom prst="rect">
             <a:avLst/>
@@ -22010,14 +22010,14 @@
           <a:noFill/>
         </p:spPr>
         <p:txBody>
-          <a:bodyPr wrap="square" lIns="0" rIns="0" tIns="0" bIns="0">
+          <a:bodyPr wrap="none" lIns="0" rIns="0" tIns="0" bIns="0">
             <a:noAutofit/>
           </a:bodyPr>
           <a:lstStyle/>
           <a:p>
-            <a:pPr algn="l">
-              <a:lnSpc>
-                <a:spcPct val="117000"/>
+            <a:pPr algn="r">
+              <a:lnSpc>
+                <a:spcPts val="2640"/>
               </a:lnSpc>
               <a:spcBef>
                 <a:spcPts val="0"/>
@@ -22034,7 +22034,7 @@
               </a:defRPr>
             </a:pPr>
             <a:r>
-              <a:rPr sz="1250" b="1" lang="ja-JP" altLang="en-US">
+              <a:rPr sz="2200" b="1" lang="ja-JP" altLang="en-US">
                 <a:solidFill>
                   <a:srgbClr val="2C9100"/>
                 </a:solidFill>
@@ -22431,8 +22431,8 @@
         </p:nvSpPr>
         <p:spPr>
           <a:xfrm>
-            <a:off x="6583680" y="1271016"/>
-            <a:ext cx="1965960" cy="201168"/>
+            <a:off x="5303520" y="1216152"/>
+            <a:ext cx="3246120" cy="384048"/>
           </a:xfrm>
           <a:prstGeom prst="rect">
             <a:avLst/>
@@ -22440,14 +22440,14 @@
           <a:noFill/>
         </p:spPr>
         <p:txBody>
-          <a:bodyPr wrap="square" lIns="0" rIns="0" tIns="0" bIns="0">
+          <a:bodyPr wrap="none" lIns="0" rIns="0" tIns="0" bIns="0">
             <a:noAutofit/>
           </a:bodyPr>
           <a:lstStyle/>
           <a:p>
-            <a:pPr algn="l">
-              <a:lnSpc>
-                <a:spcPct val="117000"/>
+            <a:pPr algn="r">
+              <a:lnSpc>
+                <a:spcPts val="2640"/>
               </a:lnSpc>
               <a:spcBef>
                 <a:spcPts val="0"/>
@@ -22464,7 +22464,7 @@
               </a:defRPr>
             </a:pPr>
             <a:r>
-              <a:rPr sz="1250" b="1" lang="ja-JP" altLang="en-US">
+              <a:rPr sz="2200" b="1" lang="ja-JP" altLang="en-US">
                 <a:solidFill>
                   <a:srgbClr val="2C9100"/>
                 </a:solidFill>
@@ -22982,8 +22982,8 @@
         </p:nvSpPr>
         <p:spPr>
           <a:xfrm>
-            <a:off x="6583680" y="1271016"/>
-            <a:ext cx="1965960" cy="201168"/>
+            <a:off x="5303520" y="1216152"/>
+            <a:ext cx="3246120" cy="384048"/>
           </a:xfrm>
           <a:prstGeom prst="rect">
             <a:avLst/>
@@ -22991,14 +22991,14 @@
           <a:noFill/>
         </p:spPr>
         <p:txBody>
-          <a:bodyPr wrap="square" lIns="0" rIns="0" tIns="0" bIns="0">
+          <a:bodyPr wrap="none" lIns="0" rIns="0" tIns="0" bIns="0">
             <a:noAutofit/>
           </a:bodyPr>
           <a:lstStyle/>
           <a:p>
-            <a:pPr algn="l">
-              <a:lnSpc>
-                <a:spcPct val="117000"/>
+            <a:pPr algn="r">
+              <a:lnSpc>
+                <a:spcPts val="2640"/>
               </a:lnSpc>
               <a:spcBef>
                 <a:spcPts val="0"/>
@@ -23015,7 +23015,7 @@
               </a:defRPr>
             </a:pPr>
             <a:r>
-              <a:rPr sz="1250" b="1" lang="ja-JP" altLang="en-US">
+              <a:rPr sz="2200" b="1" lang="ja-JP" altLang="en-US">
                 <a:solidFill>
                   <a:srgbClr val="2C9100"/>
                 </a:solidFill>
@@ -23471,8 +23471,8 @@
         </p:nvSpPr>
         <p:spPr>
           <a:xfrm>
-            <a:off x="6583680" y="1271016"/>
-            <a:ext cx="1965960" cy="201168"/>
+            <a:off x="5303520" y="1216152"/>
+            <a:ext cx="3246120" cy="384048"/>
           </a:xfrm>
           <a:prstGeom prst="rect">
             <a:avLst/>
@@ -23480,14 +23480,14 @@
           <a:noFill/>
         </p:spPr>
         <p:txBody>
-          <a:bodyPr wrap="square" lIns="0" rIns="0" tIns="0" bIns="0">
+          <a:bodyPr wrap="none" lIns="0" rIns="0" tIns="0" bIns="0">
             <a:noAutofit/>
           </a:bodyPr>
           <a:lstStyle/>
           <a:p>
-            <a:pPr algn="l">
-              <a:lnSpc>
-                <a:spcPct val="117000"/>
+            <a:pPr algn="r">
+              <a:lnSpc>
+                <a:spcPts val="2640"/>
               </a:lnSpc>
               <a:spcBef>
                 <a:spcPts val="0"/>
@@ -23504,7 +23504,7 @@
               </a:defRPr>
             </a:pPr>
             <a:r>
-              <a:rPr sz="1250" b="1" lang="ja-JP" altLang="en-US">
+              <a:rPr sz="2200" b="1" lang="ja-JP" altLang="en-US">
                 <a:solidFill>
                   <a:srgbClr val="2C9100"/>
                 </a:solidFill>
@@ -24084,8 +24084,8 @@
         </p:nvSpPr>
         <p:spPr>
           <a:xfrm>
-            <a:off x="6583680" y="1271016"/>
-            <a:ext cx="1965960" cy="201168"/>
+            <a:off x="5303520" y="1216152"/>
+            <a:ext cx="3246120" cy="384048"/>
           </a:xfrm>
           <a:prstGeom prst="rect">
             <a:avLst/>
@@ -24093,14 +24093,14 @@
           <a:noFill/>
         </p:spPr>
         <p:txBody>
-          <a:bodyPr wrap="square" lIns="0" rIns="0" tIns="0" bIns="0">
+          <a:bodyPr wrap="none" lIns="0" rIns="0" tIns="0" bIns="0">
             <a:noAutofit/>
           </a:bodyPr>
           <a:lstStyle/>
           <a:p>
-            <a:pPr algn="l">
-              <a:lnSpc>
-                <a:spcPct val="117000"/>
+            <a:pPr algn="r">
+              <a:lnSpc>
+                <a:spcPts val="2640"/>
               </a:lnSpc>
               <a:spcBef>
                 <a:spcPts val="0"/>
@@ -24117,7 +24117,7 @@
               </a:defRPr>
             </a:pPr>
             <a:r>
-              <a:rPr sz="1250" b="1" lang="ja-JP" altLang="en-US">
+              <a:rPr sz="2200" b="1" lang="ja-JP" altLang="en-US">
                 <a:solidFill>
                   <a:srgbClr val="2C9100"/>
                 </a:solidFill>
@@ -24511,8 +24511,8 @@
         </p:nvSpPr>
         <p:spPr>
           <a:xfrm>
-            <a:off x="6583680" y="1271016"/>
-            <a:ext cx="1965960" cy="201168"/>
+            <a:off x="5303520" y="1216152"/>
+            <a:ext cx="3246120" cy="384048"/>
           </a:xfrm>
           <a:prstGeom prst="rect">
             <a:avLst/>
@@ -24520,14 +24520,14 @@
           <a:noFill/>
         </p:spPr>
         <p:txBody>
-          <a:bodyPr wrap="square" lIns="0" rIns="0" tIns="0" bIns="0">
+          <a:bodyPr wrap="none" lIns="0" rIns="0" tIns="0" bIns="0">
             <a:noAutofit/>
           </a:bodyPr>
           <a:lstStyle/>
           <a:p>
-            <a:pPr algn="l">
-              <a:lnSpc>
-                <a:spcPct val="117000"/>
+            <a:pPr algn="r">
+              <a:lnSpc>
+                <a:spcPts val="2640"/>
               </a:lnSpc>
               <a:spcBef>
                 <a:spcPts val="0"/>
@@ -24544,7 +24544,7 @@
               </a:defRPr>
             </a:pPr>
             <a:r>
-              <a:rPr sz="1250" b="1" lang="ja-JP" altLang="en-US">
+              <a:rPr sz="2200" b="1" lang="ja-JP" altLang="en-US">
                 <a:solidFill>
                   <a:srgbClr val="2C9100"/>
                 </a:solidFill>
@@ -25127,8 +25127,8 @@
         </p:nvSpPr>
         <p:spPr>
           <a:xfrm>
-            <a:off x="6583680" y="1271016"/>
-            <a:ext cx="1965960" cy="201168"/>
+            <a:off x="5303520" y="1216152"/>
+            <a:ext cx="3246120" cy="384048"/>
           </a:xfrm>
           <a:prstGeom prst="rect">
             <a:avLst/>
@@ -25136,14 +25136,14 @@
           <a:noFill/>
         </p:spPr>
         <p:txBody>
-          <a:bodyPr wrap="square" lIns="0" rIns="0" tIns="0" bIns="0">
+          <a:bodyPr wrap="none" lIns="0" rIns="0" tIns="0" bIns="0">
             <a:noAutofit/>
           </a:bodyPr>
           <a:lstStyle/>
           <a:p>
-            <a:pPr algn="l">
-              <a:lnSpc>
-                <a:spcPct val="117000"/>
+            <a:pPr algn="r">
+              <a:lnSpc>
+                <a:spcPts val="2640"/>
               </a:lnSpc>
               <a:spcBef>
                 <a:spcPts val="0"/>
@@ -25160,7 +25160,7 @@
               </a:defRPr>
             </a:pPr>
             <a:r>
-              <a:rPr sz="1250" b="1" lang="ja-JP" altLang="en-US">
+              <a:rPr sz="2200" b="1" lang="ja-JP" altLang="en-US">
                 <a:solidFill>
                   <a:srgbClr val="2C9100"/>
                 </a:solidFill>
@@ -30118,8 +30118,8 @@
         </p:nvSpPr>
         <p:spPr>
           <a:xfrm>
-            <a:off x="6583680" y="1271016"/>
-            <a:ext cx="1965960" cy="201168"/>
+            <a:off x="5303520" y="1216152"/>
+            <a:ext cx="3246120" cy="384048"/>
           </a:xfrm>
           <a:prstGeom prst="rect">
             <a:avLst/>
@@ -30127,14 +30127,14 @@
           <a:noFill/>
         </p:spPr>
         <p:txBody>
-          <a:bodyPr wrap="square" lIns="0" rIns="0" tIns="0" bIns="0">
+          <a:bodyPr wrap="none" lIns="0" rIns="0" tIns="0" bIns="0">
             <a:noAutofit/>
           </a:bodyPr>
           <a:lstStyle/>
           <a:p>
-            <a:pPr algn="l">
-              <a:lnSpc>
-                <a:spcPct val="117000"/>
+            <a:pPr algn="r">
+              <a:lnSpc>
+                <a:spcPts val="2640"/>
               </a:lnSpc>
               <a:spcBef>
                 <a:spcPts val="0"/>
@@ -30151,7 +30151,7 @@
               </a:defRPr>
             </a:pPr>
             <a:r>
-              <a:rPr sz="1250" b="1" lang="ja-JP" altLang="en-US">
+              <a:rPr sz="2200" b="1" lang="ja-JP" altLang="en-US">
                 <a:solidFill>
                   <a:srgbClr val="2C9100"/>
                 </a:solidFill>
@@ -30731,8 +30731,8 @@
         </p:nvSpPr>
         <p:spPr>
           <a:xfrm>
-            <a:off x="6583680" y="1271016"/>
-            <a:ext cx="1965960" cy="201168"/>
+            <a:off x="5303520" y="1216152"/>
+            <a:ext cx="3246120" cy="384048"/>
           </a:xfrm>
           <a:prstGeom prst="rect">
             <a:avLst/>
@@ -30740,14 +30740,14 @@
           <a:noFill/>
         </p:spPr>
         <p:txBody>
-          <a:bodyPr wrap="square" lIns="0" rIns="0" tIns="0" bIns="0">
+          <a:bodyPr wrap="none" lIns="0" rIns="0" tIns="0" bIns="0">
             <a:noAutofit/>
           </a:bodyPr>
           <a:lstStyle/>
           <a:p>
-            <a:pPr algn="l">
-              <a:lnSpc>
-                <a:spcPct val="117000"/>
+            <a:pPr algn="r">
+              <a:lnSpc>
+                <a:spcPts val="2640"/>
               </a:lnSpc>
               <a:spcBef>
                 <a:spcPts val="0"/>
@@ -30764,7 +30764,7 @@
               </a:defRPr>
             </a:pPr>
             <a:r>
-              <a:rPr sz="1250" b="1" lang="ja-JP" altLang="en-US">
+              <a:rPr sz="2200" b="1" lang="ja-JP" altLang="en-US">
                 <a:solidFill>
                   <a:srgbClr val="2C9100"/>
                 </a:solidFill>
@@ -31158,8 +31158,8 @@
         </p:nvSpPr>
         <p:spPr>
           <a:xfrm>
-            <a:off x="6583680" y="1271016"/>
-            <a:ext cx="1965960" cy="201168"/>
+            <a:off x="5303520" y="1216152"/>
+            <a:ext cx="3246120" cy="384048"/>
           </a:xfrm>
           <a:prstGeom prst="rect">
             <a:avLst/>
@@ -31167,14 +31167,14 @@
           <a:noFill/>
         </p:spPr>
         <p:txBody>
-          <a:bodyPr wrap="square" lIns="0" rIns="0" tIns="0" bIns="0">
+          <a:bodyPr wrap="none" lIns="0" rIns="0" tIns="0" bIns="0">
             <a:noAutofit/>
           </a:bodyPr>
           <a:lstStyle/>
           <a:p>
-            <a:pPr algn="l">
-              <a:lnSpc>
-                <a:spcPct val="117000"/>
+            <a:pPr algn="r">
+              <a:lnSpc>
+                <a:spcPts val="2640"/>
               </a:lnSpc>
               <a:spcBef>
                 <a:spcPts val="0"/>
@@ -31191,7 +31191,7 @@
               </a:defRPr>
             </a:pPr>
             <a:r>
-              <a:rPr sz="1250" b="1" lang="ja-JP" altLang="en-US">
+              <a:rPr sz="2200" b="1" lang="ja-JP" altLang="en-US">
                 <a:solidFill>
                   <a:srgbClr val="2C9100"/>
                 </a:solidFill>

</xml_diff>

<commit_message>
slides(bbq): use burgundy theme accent for answers
</commit_message>
<xml_diff>
--- a/slides/datasets-in-10-minutes-bbq.pptx
+++ b/slides/datasets-in-10-minutes-bbq.pptx
@@ -7709,7 +7709,7 @@
             <a:r>
               <a:rPr sz="2200" b="1" lang="ja-JP" altLang="en-US">
                 <a:solidFill>
-                  <a:srgbClr val="2C9100"/>
+                  <a:schemeClr val="accent1"/>
                 </a:solidFill>
                 <a:latin typeface="Noto Sans"/>
                 <a:ea typeface="Noto Sans CJK JP"/>
@@ -8322,7 +8322,7 @@
             <a:r>
               <a:rPr sz="2200" b="1" lang="ja-JP" altLang="en-US">
                 <a:solidFill>
-                  <a:srgbClr val="2C9100"/>
+                  <a:schemeClr val="accent1"/>
                 </a:solidFill>
                 <a:latin typeface="Noto Sans"/>
                 <a:ea typeface="Noto Sans CJK JP"/>
@@ -8814,7 +8814,7 @@
             <a:r>
               <a:rPr sz="2200" b="1" lang="ja-JP" altLang="en-US">
                 <a:solidFill>
-                  <a:srgbClr val="2C9100"/>
+                  <a:schemeClr val="accent1"/>
                 </a:solidFill>
                 <a:latin typeface="Noto Sans"/>
                 <a:ea typeface="Noto Sans CJK JP"/>
@@ -15042,7 +15042,7 @@
             <a:r>
               <a:rPr sz="2200" b="1" lang="ja-JP" altLang="en-US">
                 <a:solidFill>
-                  <a:srgbClr val="2C9100"/>
+                  <a:schemeClr val="accent1"/>
                 </a:solidFill>
                 <a:latin typeface="Noto Sans"/>
                 <a:ea typeface="Noto Sans CJK JP"/>
@@ -15593,7 +15593,7 @@
             <a:r>
               <a:rPr sz="2200" b="1" lang="ja-JP" altLang="en-US">
                 <a:solidFill>
-                  <a:srgbClr val="2C9100"/>
+                  <a:schemeClr val="accent1"/>
                 </a:solidFill>
                 <a:latin typeface="Noto Sans"/>
                 <a:ea typeface="Noto Sans CJK JP"/>
@@ -16082,7 +16082,7 @@
             <a:r>
               <a:rPr sz="2200" b="1" lang="ja-JP" altLang="en-US">
                 <a:solidFill>
-                  <a:srgbClr val="2C9100"/>
+                  <a:schemeClr val="accent1"/>
                 </a:solidFill>
                 <a:latin typeface="Noto Sans"/>
                 <a:ea typeface="Noto Sans CJK JP"/>
@@ -16698,7 +16698,7 @@
             <a:r>
               <a:rPr sz="2200" b="1" lang="ja-JP" altLang="en-US">
                 <a:solidFill>
-                  <a:srgbClr val="2C9100"/>
+                  <a:schemeClr val="accent1"/>
                 </a:solidFill>
                 <a:latin typeface="Noto Sans"/>
                 <a:ea typeface="Noto Sans CJK JP"/>
@@ -17128,7 +17128,7 @@
             <a:r>
               <a:rPr sz="2200" b="1" lang="ja-JP" altLang="en-US">
                 <a:solidFill>
-                  <a:srgbClr val="2C9100"/>
+                  <a:schemeClr val="accent1"/>
                 </a:solidFill>
                 <a:latin typeface="Noto Sans"/>
                 <a:ea typeface="Noto Sans CJK JP"/>
@@ -17558,7 +17558,7 @@
             <a:r>
               <a:rPr sz="2200" b="1" lang="ja-JP" altLang="en-US">
                 <a:solidFill>
-                  <a:srgbClr val="2C9100"/>
+                  <a:schemeClr val="accent1"/>
                 </a:solidFill>
                 <a:latin typeface="Noto Sans"/>
                 <a:ea typeface="Noto Sans CJK JP"/>
@@ -18174,7 +18174,7 @@
             <a:r>
               <a:rPr sz="2200" b="1" lang="ja-JP" altLang="en-US">
                 <a:solidFill>
-                  <a:srgbClr val="2C9100"/>
+                  <a:schemeClr val="accent1"/>
                 </a:solidFill>
                 <a:latin typeface="Noto Sans"/>
                 <a:ea typeface="Noto Sans CJK JP"/>
@@ -18790,7 +18790,7 @@
             <a:r>
               <a:rPr sz="2200" b="1" lang="ja-JP" altLang="en-US">
                 <a:solidFill>
-                  <a:srgbClr val="2C9100"/>
+                  <a:schemeClr val="accent1"/>
                 </a:solidFill>
                 <a:latin typeface="Noto Sans"/>
                 <a:ea typeface="Noto Sans CJK JP"/>
@@ -19220,7 +19220,7 @@
             <a:r>
               <a:rPr sz="2200" b="1" lang="ja-JP" altLang="en-US">
                 <a:solidFill>
-                  <a:srgbClr val="2C9100"/>
+                  <a:schemeClr val="accent1"/>
                 </a:solidFill>
                 <a:latin typeface="Noto Sans"/>
                 <a:ea typeface="Noto Sans CJK JP"/>
@@ -19833,7 +19833,7 @@
             <a:r>
               <a:rPr sz="2200" b="1" lang="ja-JP" altLang="en-US">
                 <a:solidFill>
-                  <a:srgbClr val="2C9100"/>
+                  <a:schemeClr val="accent1"/>
                 </a:solidFill>
                 <a:latin typeface="Noto Sans"/>
                 <a:ea typeface="Noto Sans CJK JP"/>
@@ -20374,7 +20374,7 @@
             <a:r>
               <a:rPr sz="2200" b="1" lang="ja-JP" altLang="en-US">
                 <a:solidFill>
-                  <a:srgbClr val="2C9100"/>
+                  <a:schemeClr val="accent1"/>
                 </a:solidFill>
                 <a:latin typeface="Noto Sans"/>
                 <a:ea typeface="Noto Sans CJK JP"/>
@@ -20990,7 +20990,7 @@
             <a:r>
               <a:rPr sz="2200" b="1" lang="ja-JP" altLang="en-US">
                 <a:solidFill>
-                  <a:srgbClr val="2C9100"/>
+                  <a:schemeClr val="accent1"/>
                 </a:solidFill>
                 <a:latin typeface="Noto Sans"/>
                 <a:ea typeface="Noto Sans CJK JP"/>
@@ -21420,7 +21420,7 @@
             <a:r>
               <a:rPr sz="2200" b="1" lang="ja-JP" altLang="en-US">
                 <a:solidFill>
-                  <a:srgbClr val="2C9100"/>
+                  <a:schemeClr val="accent1"/>
                 </a:solidFill>
                 <a:latin typeface="Noto Sans"/>
                 <a:ea typeface="Noto Sans CJK JP"/>
@@ -22036,7 +22036,7 @@
             <a:r>
               <a:rPr sz="2200" b="1" lang="ja-JP" altLang="en-US">
                 <a:solidFill>
-                  <a:srgbClr val="2C9100"/>
+                  <a:schemeClr val="accent1"/>
                 </a:solidFill>
                 <a:latin typeface="Noto Sans"/>
                 <a:ea typeface="Noto Sans CJK JP"/>
@@ -22466,7 +22466,7 @@
             <a:r>
               <a:rPr sz="2200" b="1" lang="ja-JP" altLang="en-US">
                 <a:solidFill>
-                  <a:srgbClr val="2C9100"/>
+                  <a:schemeClr val="accent1"/>
                 </a:solidFill>
                 <a:latin typeface="Noto Sans"/>
                 <a:ea typeface="Noto Sans CJK JP"/>
@@ -23017,7 +23017,7 @@
             <a:r>
               <a:rPr sz="2200" b="1" lang="ja-JP" altLang="en-US">
                 <a:solidFill>
-                  <a:srgbClr val="2C9100"/>
+                  <a:schemeClr val="accent1"/>
                 </a:solidFill>
                 <a:latin typeface="Noto Sans"/>
                 <a:ea typeface="Noto Sans CJK JP"/>
@@ -23506,7 +23506,7 @@
             <a:r>
               <a:rPr sz="2200" b="1" lang="ja-JP" altLang="en-US">
                 <a:solidFill>
-                  <a:srgbClr val="2C9100"/>
+                  <a:schemeClr val="accent1"/>
                 </a:solidFill>
                 <a:latin typeface="Noto Sans"/>
                 <a:ea typeface="Noto Sans CJK JP"/>
@@ -24119,7 +24119,7 @@
             <a:r>
               <a:rPr sz="2200" b="1" lang="ja-JP" altLang="en-US">
                 <a:solidFill>
-                  <a:srgbClr val="2C9100"/>
+                  <a:schemeClr val="accent1"/>
                 </a:solidFill>
                 <a:latin typeface="Noto Sans"/>
                 <a:ea typeface="Noto Sans CJK JP"/>
@@ -24546,7 +24546,7 @@
             <a:r>
               <a:rPr sz="2200" b="1" lang="ja-JP" altLang="en-US">
                 <a:solidFill>
-                  <a:srgbClr val="2C9100"/>
+                  <a:schemeClr val="accent1"/>
                 </a:solidFill>
                 <a:latin typeface="Noto Sans"/>
                 <a:ea typeface="Noto Sans CJK JP"/>
@@ -25162,7 +25162,7 @@
             <a:r>
               <a:rPr sz="2200" b="1" lang="ja-JP" altLang="en-US">
                 <a:solidFill>
-                  <a:srgbClr val="2C9100"/>
+                  <a:schemeClr val="accent1"/>
                 </a:solidFill>
                 <a:latin typeface="Noto Sans"/>
                 <a:ea typeface="Noto Sans CJK JP"/>
@@ -30153,7 +30153,7 @@
             <a:r>
               <a:rPr sz="2200" b="1" lang="ja-JP" altLang="en-US">
                 <a:solidFill>
-                  <a:srgbClr val="2C9100"/>
+                  <a:schemeClr val="accent1"/>
                 </a:solidFill>
                 <a:latin typeface="Noto Sans"/>
                 <a:ea typeface="Noto Sans CJK JP"/>
@@ -30766,7 +30766,7 @@
             <a:r>
               <a:rPr sz="2200" b="1" lang="ja-JP" altLang="en-US">
                 <a:solidFill>
-                  <a:srgbClr val="2C9100"/>
+                  <a:schemeClr val="accent1"/>
                 </a:solidFill>
                 <a:latin typeface="Noto Sans"/>
                 <a:ea typeface="Noto Sans CJK JP"/>
@@ -31193,7 +31193,7 @@
             <a:r>
               <a:rPr sz="2200" b="1" lang="ja-JP" altLang="en-US">
                 <a:solidFill>
-                  <a:srgbClr val="2C9100"/>
+                  <a:schemeClr val="accent1"/>
                 </a:solidFill>
                 <a:latin typeface="Noto Sans"/>
                 <a:ea typeface="Noto Sans CJK JP"/>

</xml_diff>